<commit_message>
Balance colors and tighten card spacing in worksheet decks
Rotate accent colors (teal / amber / navy / plum) across multi-card
slides (terms / goals / brushup) instead of repeating teal. Shrink
card heights so empty space below short text disappears
(terms 3.4→2.3in, brushup 3.85→3.6in, goals 3.2→2.5in), and drop the
redundant "STEP1: 用語・前提" subtitle that duplicated the slide title.

https://claude.ai/code/session_01MLnStsm4YQNeGye3rc2BGH
</commit_message>
<xml_diff>
--- a/lecture_pptx/out/work01_basic_student.pptx
+++ b/lecture_pptx/out/work01_basic_student.pptx
@@ -1695,20 +1695,20 @@
         </p:nvSpPr>
         <p:spPr>
           <a:xfrm>
-            <a:off x="411480" y="1463040"/>
-            <a:ext cx="2651760" cy="2926080"/>
+            <a:off x="411480" y="1325880"/>
+            <a:ext cx="2651760" cy="2286000"/>
           </a:xfrm>
           <a:prstGeom prst="roundRect">
             <a:avLst>
-              <a:gd name="adj" fmla="val 3448"/>
+              <a:gd name="adj" fmla="val 4000"/>
             </a:avLst>
           </a:prstGeom>
           <a:solidFill>
             <a:srgbClr val="F4F6F9"/>
           </a:solidFill>
-          <a:ln w="6350">
+          <a:ln w="19050">
             <a:solidFill>
-              <a:srgbClr val="D7DCE3"/>
+              <a:srgbClr val="0E7C86"/>
             </a:solidFill>
             <a:prstDash val="solid"/>
           </a:ln>
@@ -1716,14 +1716,34 @@
       </p:sp>
       <p:sp>
         <p:nvSpPr>
-          <p:cNvPr id="5" name="Text 3"/>
-          <p:cNvSpPr/>
-          <p:nvPr/>
-        </p:nvSpPr>
-        <p:spPr>
-          <a:xfrm>
-            <a:off x="594360" y="1645920"/>
-            <a:ext cx="731520" cy="502920"/>
+          <p:cNvPr id="5" name="Shape 3"/>
+          <p:cNvSpPr/>
+          <p:nvPr/>
+        </p:nvSpPr>
+        <p:spPr>
+          <a:xfrm>
+            <a:off x="502920" y="1325880"/>
+            <a:ext cx="2468880" cy="54864"/>
+          </a:xfrm>
+          <a:prstGeom prst="rect">
+            <a:avLst/>
+          </a:prstGeom>
+          <a:solidFill>
+            <a:srgbClr val="0E7C86"/>
+          </a:solidFill>
+          <a:ln/>
+        </p:spPr>
+      </p:sp>
+      <p:sp>
+        <p:nvSpPr>
+          <p:cNvPr id="6" name="Text 4"/>
+          <p:cNvSpPr/>
+          <p:nvPr/>
+        </p:nvSpPr>
+        <p:spPr>
+          <a:xfrm>
+            <a:off x="594360" y="1463040"/>
+            <a:ext cx="777240" cy="502920"/>
           </a:xfrm>
           <a:prstGeom prst="rect">
             <a:avLst/>
@@ -1739,7 +1759,7 @@
               <a:buNone/>
             </a:pPr>
             <a:r>
-              <a:rPr lang="en-US" sz="2600" b="1" dirty="0">
+              <a:rPr lang="en-US" sz="2400" b="1" dirty="0">
                 <a:solidFill>
                   <a:srgbClr val="0E7C86"/>
                 </a:solidFill>
@@ -1749,20 +1769,20 @@
               </a:rPr>
               <a:t>01</a:t>
             </a:r>
-            <a:endParaRPr lang="en-US" sz="2600" dirty="0"/>
-          </a:p>
-        </p:txBody>
-      </p:sp>
-      <p:sp>
-        <p:nvSpPr>
-          <p:cNvPr id="6" name="Text 4"/>
-          <p:cNvSpPr/>
-          <p:nvPr/>
-        </p:nvSpPr>
-        <p:spPr>
-          <a:xfrm>
-            <a:off x="594360" y="2240280"/>
-            <a:ext cx="2286000" cy="640080"/>
+            <a:endParaRPr lang="en-US" sz="2400" dirty="0"/>
+          </a:p>
+        </p:txBody>
+      </p:sp>
+      <p:sp>
+        <p:nvSpPr>
+          <p:cNvPr id="7" name="Text 5"/>
+          <p:cNvSpPr/>
+          <p:nvPr/>
+        </p:nvSpPr>
+        <p:spPr>
+          <a:xfrm>
+            <a:off x="594360" y="1984248"/>
+            <a:ext cx="2286000" cy="502920"/>
           </a:xfrm>
           <a:prstGeom prst="rect">
             <a:avLst/>
@@ -1778,7 +1798,7 @@
               <a:buNone/>
             </a:pPr>
             <a:r>
-              <a:rPr lang="en-US" sz="1500" b="1" dirty="0">
+              <a:rPr lang="en-US" sz="1400" b="1" dirty="0">
                 <a:solidFill>
                   <a:srgbClr val="1F3A5F"/>
                 </a:solidFill>
@@ -1788,20 +1808,20 @@
               </a:rPr>
               <a:t>AIに頼んで LP を作る</a:t>
             </a:r>
-            <a:endParaRPr lang="en-US" sz="1500" dirty="0"/>
-          </a:p>
-        </p:txBody>
-      </p:sp>
-      <p:sp>
-        <p:nvSpPr>
-          <p:cNvPr id="7" name="Text 5"/>
-          <p:cNvSpPr/>
-          <p:nvPr/>
-        </p:nvSpPr>
-        <p:spPr>
-          <a:xfrm>
-            <a:off x="594360" y="2926080"/>
-            <a:ext cx="2286000" cy="1280160"/>
+            <a:endParaRPr lang="en-US" sz="1400" dirty="0"/>
+          </a:p>
+        </p:txBody>
+      </p:sp>
+      <p:sp>
+        <p:nvSpPr>
+          <p:cNvPr id="8" name="Text 6"/>
+          <p:cNvSpPr/>
+          <p:nvPr/>
+        </p:nvSpPr>
+        <p:spPr>
+          <a:xfrm>
+            <a:off x="594360" y="2514600"/>
+            <a:ext cx="2286000" cy="1005840"/>
           </a:xfrm>
           <a:prstGeom prst="rect">
             <a:avLst/>
@@ -1833,26 +1853,26 @@
       </p:sp>
       <p:sp>
         <p:nvSpPr>
-          <p:cNvPr id="8" name="Shape 6"/>
-          <p:cNvSpPr/>
-          <p:nvPr/>
-        </p:nvSpPr>
-        <p:spPr>
-          <a:xfrm>
-            <a:off x="3246120" y="1463040"/>
-            <a:ext cx="2651760" cy="2926080"/>
+          <p:cNvPr id="9" name="Shape 7"/>
+          <p:cNvSpPr/>
+          <p:nvPr/>
+        </p:nvSpPr>
+        <p:spPr>
+          <a:xfrm>
+            <a:off x="3246120" y="1325880"/>
+            <a:ext cx="2651760" cy="2286000"/>
           </a:xfrm>
           <a:prstGeom prst="roundRect">
             <a:avLst>
-              <a:gd name="adj" fmla="val 3448"/>
+              <a:gd name="adj" fmla="val 4000"/>
             </a:avLst>
           </a:prstGeom>
           <a:solidFill>
             <a:srgbClr val="F4F6F9"/>
           </a:solidFill>
-          <a:ln w="6350">
+          <a:ln w="19050">
             <a:solidFill>
-              <a:srgbClr val="D7DCE3"/>
+              <a:srgbClr val="E8A33D"/>
             </a:solidFill>
             <a:prstDash val="solid"/>
           </a:ln>
@@ -1860,14 +1880,34 @@
       </p:sp>
       <p:sp>
         <p:nvSpPr>
-          <p:cNvPr id="9" name="Text 7"/>
-          <p:cNvSpPr/>
-          <p:nvPr/>
-        </p:nvSpPr>
-        <p:spPr>
-          <a:xfrm>
-            <a:off x="3429000" y="1645920"/>
-            <a:ext cx="731520" cy="502920"/>
+          <p:cNvPr id="10" name="Shape 8"/>
+          <p:cNvSpPr/>
+          <p:nvPr/>
+        </p:nvSpPr>
+        <p:spPr>
+          <a:xfrm>
+            <a:off x="3337560" y="1325880"/>
+            <a:ext cx="2468880" cy="54864"/>
+          </a:xfrm>
+          <a:prstGeom prst="rect">
+            <a:avLst/>
+          </a:prstGeom>
+          <a:solidFill>
+            <a:srgbClr val="E8A33D"/>
+          </a:solidFill>
+          <a:ln/>
+        </p:spPr>
+      </p:sp>
+      <p:sp>
+        <p:nvSpPr>
+          <p:cNvPr id="11" name="Text 9"/>
+          <p:cNvSpPr/>
+          <p:nvPr/>
+        </p:nvSpPr>
+        <p:spPr>
+          <a:xfrm>
+            <a:off x="3429000" y="1463040"/>
+            <a:ext cx="777240" cy="502920"/>
           </a:xfrm>
           <a:prstGeom prst="rect">
             <a:avLst/>
@@ -1883,9 +1923,9 @@
               <a:buNone/>
             </a:pPr>
             <a:r>
-              <a:rPr lang="en-US" sz="2600" b="1" dirty="0">
-                <a:solidFill>
-                  <a:srgbClr val="0E7C86"/>
+              <a:rPr lang="en-US" sz="2400" b="1" dirty="0">
+                <a:solidFill>
+                  <a:srgbClr val="E8A33D"/>
                 </a:solidFill>
                 <a:latin typeface="Yu Gothic UI Semibold" pitchFamily="34" charset="0"/>
                 <a:ea typeface="Yu Gothic UI Semibold" pitchFamily="34" charset="-122"/>
@@ -1893,20 +1933,20 @@
               </a:rPr>
               <a:t>02</a:t>
             </a:r>
-            <a:endParaRPr lang="en-US" sz="2600" dirty="0"/>
-          </a:p>
-        </p:txBody>
-      </p:sp>
-      <p:sp>
-        <p:nvSpPr>
-          <p:cNvPr id="10" name="Text 8"/>
-          <p:cNvSpPr/>
-          <p:nvPr/>
-        </p:nvSpPr>
-        <p:spPr>
-          <a:xfrm>
-            <a:off x="3429000" y="2240280"/>
-            <a:ext cx="2286000" cy="640080"/>
+            <a:endParaRPr lang="en-US" sz="2400" dirty="0"/>
+          </a:p>
+        </p:txBody>
+      </p:sp>
+      <p:sp>
+        <p:nvSpPr>
+          <p:cNvPr id="12" name="Text 10"/>
+          <p:cNvSpPr/>
+          <p:nvPr/>
+        </p:nvSpPr>
+        <p:spPr>
+          <a:xfrm>
+            <a:off x="3429000" y="1984248"/>
+            <a:ext cx="2286000" cy="502920"/>
           </a:xfrm>
           <a:prstGeom prst="rect">
             <a:avLst/>
@@ -1922,7 +1962,7 @@
               <a:buNone/>
             </a:pPr>
             <a:r>
-              <a:rPr lang="en-US" sz="1500" b="1" dirty="0">
+              <a:rPr lang="en-US" sz="1400" b="1" dirty="0">
                 <a:solidFill>
                   <a:srgbClr val="1F3A5F"/>
                 </a:solidFill>
@@ -1932,20 +1972,20 @@
               </a:rPr>
               <a:t>公開URLまで持っていく</a:t>
             </a:r>
-            <a:endParaRPr lang="en-US" sz="1500" dirty="0"/>
-          </a:p>
-        </p:txBody>
-      </p:sp>
-      <p:sp>
-        <p:nvSpPr>
-          <p:cNvPr id="11" name="Text 9"/>
-          <p:cNvSpPr/>
-          <p:nvPr/>
-        </p:nvSpPr>
-        <p:spPr>
-          <a:xfrm>
-            <a:off x="3429000" y="2926080"/>
-            <a:ext cx="2286000" cy="1280160"/>
+            <a:endParaRPr lang="en-US" sz="1400" dirty="0"/>
+          </a:p>
+        </p:txBody>
+      </p:sp>
+      <p:sp>
+        <p:nvSpPr>
+          <p:cNvPr id="13" name="Text 11"/>
+          <p:cNvSpPr/>
+          <p:nvPr/>
+        </p:nvSpPr>
+        <p:spPr>
+          <a:xfrm>
+            <a:off x="3429000" y="2514600"/>
+            <a:ext cx="2286000" cy="1005840"/>
           </a:xfrm>
           <a:prstGeom prst="rect">
             <a:avLst/>
@@ -1977,26 +2017,26 @@
       </p:sp>
       <p:sp>
         <p:nvSpPr>
-          <p:cNvPr id="12" name="Shape 10"/>
-          <p:cNvSpPr/>
-          <p:nvPr/>
-        </p:nvSpPr>
-        <p:spPr>
-          <a:xfrm>
-            <a:off x="6080760" y="1463040"/>
-            <a:ext cx="2651760" cy="2926080"/>
+          <p:cNvPr id="14" name="Shape 12"/>
+          <p:cNvSpPr/>
+          <p:nvPr/>
+        </p:nvSpPr>
+        <p:spPr>
+          <a:xfrm>
+            <a:off x="6080760" y="1325880"/>
+            <a:ext cx="2651760" cy="2286000"/>
           </a:xfrm>
           <a:prstGeom prst="roundRect">
             <a:avLst>
-              <a:gd name="adj" fmla="val 3448"/>
+              <a:gd name="adj" fmla="val 4000"/>
             </a:avLst>
           </a:prstGeom>
           <a:solidFill>
             <a:srgbClr val="F4F6F9"/>
           </a:solidFill>
-          <a:ln w="6350">
+          <a:ln w="19050">
             <a:solidFill>
-              <a:srgbClr val="D7DCE3"/>
+              <a:srgbClr val="1F3A5F"/>
             </a:solidFill>
             <a:prstDash val="solid"/>
           </a:ln>
@@ -2004,14 +2044,34 @@
       </p:sp>
       <p:sp>
         <p:nvSpPr>
-          <p:cNvPr id="13" name="Text 11"/>
-          <p:cNvSpPr/>
-          <p:nvPr/>
-        </p:nvSpPr>
-        <p:spPr>
-          <a:xfrm>
-            <a:off x="6263640" y="1645920"/>
-            <a:ext cx="731520" cy="502920"/>
+          <p:cNvPr id="15" name="Shape 13"/>
+          <p:cNvSpPr/>
+          <p:nvPr/>
+        </p:nvSpPr>
+        <p:spPr>
+          <a:xfrm>
+            <a:off x="6172200" y="1325880"/>
+            <a:ext cx="2468880" cy="54864"/>
+          </a:xfrm>
+          <a:prstGeom prst="rect">
+            <a:avLst/>
+          </a:prstGeom>
+          <a:solidFill>
+            <a:srgbClr val="1F3A5F"/>
+          </a:solidFill>
+          <a:ln/>
+        </p:spPr>
+      </p:sp>
+      <p:sp>
+        <p:nvSpPr>
+          <p:cNvPr id="16" name="Text 14"/>
+          <p:cNvSpPr/>
+          <p:nvPr/>
+        </p:nvSpPr>
+        <p:spPr>
+          <a:xfrm>
+            <a:off x="6263640" y="1463040"/>
+            <a:ext cx="777240" cy="502920"/>
           </a:xfrm>
           <a:prstGeom prst="rect">
             <a:avLst/>
@@ -2027,9 +2087,9 @@
               <a:buNone/>
             </a:pPr>
             <a:r>
-              <a:rPr lang="en-US" sz="2600" b="1" dirty="0">
-                <a:solidFill>
-                  <a:srgbClr val="0E7C86"/>
+              <a:rPr lang="en-US" sz="2400" b="1" dirty="0">
+                <a:solidFill>
+                  <a:srgbClr val="1F3A5F"/>
                 </a:solidFill>
                 <a:latin typeface="Yu Gothic UI Semibold" pitchFamily="34" charset="0"/>
                 <a:ea typeface="Yu Gothic UI Semibold" pitchFamily="34" charset="-122"/>
@@ -2037,20 +2097,20 @@
               </a:rPr>
               <a:t>03</a:t>
             </a:r>
-            <a:endParaRPr lang="en-US" sz="2600" dirty="0"/>
-          </a:p>
-        </p:txBody>
-      </p:sp>
-      <p:sp>
-        <p:nvSpPr>
-          <p:cNvPr id="14" name="Text 12"/>
-          <p:cNvSpPr/>
-          <p:nvPr/>
-        </p:nvSpPr>
-        <p:spPr>
-          <a:xfrm>
-            <a:off x="6263640" y="2240280"/>
-            <a:ext cx="2286000" cy="640080"/>
+            <a:endParaRPr lang="en-US" sz="2400" dirty="0"/>
+          </a:p>
+        </p:txBody>
+      </p:sp>
+      <p:sp>
+        <p:nvSpPr>
+          <p:cNvPr id="17" name="Text 15"/>
+          <p:cNvSpPr/>
+          <p:nvPr/>
+        </p:nvSpPr>
+        <p:spPr>
+          <a:xfrm>
+            <a:off x="6263640" y="1984248"/>
+            <a:ext cx="2286000" cy="502920"/>
           </a:xfrm>
           <a:prstGeom prst="rect">
             <a:avLst/>
@@ -2066,7 +2126,7 @@
               <a:buNone/>
             </a:pPr>
             <a:r>
-              <a:rPr lang="en-US" sz="1500" b="1" dirty="0">
+              <a:rPr lang="en-US" sz="1400" b="1" dirty="0">
                 <a:solidFill>
                   <a:srgbClr val="1F3A5F"/>
                 </a:solidFill>
@@ -2076,20 +2136,20 @@
               </a:rPr>
               <a:t>公式LINE登録ボタンを設置</a:t>
             </a:r>
-            <a:endParaRPr lang="en-US" sz="1500" dirty="0"/>
-          </a:p>
-        </p:txBody>
-      </p:sp>
-      <p:sp>
-        <p:nvSpPr>
-          <p:cNvPr id="15" name="Text 13"/>
-          <p:cNvSpPr/>
-          <p:nvPr/>
-        </p:nvSpPr>
-        <p:spPr>
-          <a:xfrm>
-            <a:off x="6263640" y="2926080"/>
-            <a:ext cx="2286000" cy="1280160"/>
+            <a:endParaRPr lang="en-US" sz="1400" dirty="0"/>
+          </a:p>
+        </p:txBody>
+      </p:sp>
+      <p:sp>
+        <p:nvSpPr>
+          <p:cNvPr id="18" name="Text 16"/>
+          <p:cNvSpPr/>
+          <p:nvPr/>
+        </p:nvSpPr>
+        <p:spPr>
+          <a:xfrm>
+            <a:off x="6263640" y="2514600"/>
+            <a:ext cx="2286000" cy="1005840"/>
           </a:xfrm>
           <a:prstGeom prst="rect">
             <a:avLst/>
@@ -2212,57 +2272,18 @@
       </p:sp>
       <p:sp>
         <p:nvSpPr>
-          <p:cNvPr id="4" name="Text 2"/>
-          <p:cNvSpPr/>
-          <p:nvPr/>
-        </p:nvSpPr>
-        <p:spPr>
-          <a:xfrm>
-            <a:off x="411480" y="731520"/>
-            <a:ext cx="8412480" cy="320040"/>
-          </a:xfrm>
-          <a:prstGeom prst="rect">
-            <a:avLst/>
-          </a:prstGeom>
-          <a:noFill/>
-          <a:ln/>
-        </p:spPr>
-        <p:txBody>
-          <a:bodyPr wrap="square" rtlCol="0" anchor="ctr"/>
-          <a:lstStyle/>
-          <a:p>
-            <a:pPr indent="0" marL="0">
-              <a:buNone/>
-            </a:pPr>
-            <a:r>
-              <a:rPr lang="en-US" sz="1300" i="1" dirty="0">
-                <a:solidFill>
-                  <a:srgbClr val="555555"/>
-                </a:solidFill>
-                <a:latin typeface="Yu Gothic UI" pitchFamily="34" charset="0"/>
-                <a:ea typeface="Yu Gothic UI" pitchFamily="34" charset="-122"/>
-                <a:cs typeface="Yu Gothic UI" pitchFamily="34" charset="-120"/>
-              </a:rPr>
-              <a:t>STEP1: 用語・前提</a:t>
-            </a:r>
-            <a:endParaRPr lang="en-US" sz="1300" dirty="0"/>
-          </a:p>
-        </p:txBody>
-      </p:sp>
-      <p:sp>
-        <p:nvSpPr>
-          <p:cNvPr id="5" name="Shape 3"/>
-          <p:cNvSpPr/>
-          <p:nvPr/>
-        </p:nvSpPr>
-        <p:spPr>
-          <a:xfrm>
-            <a:off x="411480" y="1280160"/>
-            <a:ext cx="1943100" cy="3108960"/>
+          <p:cNvPr id="4" name="Shape 2"/>
+          <p:cNvSpPr/>
+          <p:nvPr/>
+        </p:nvSpPr>
+        <p:spPr>
+          <a:xfrm>
+            <a:off x="365760" y="1097280"/>
+            <a:ext cx="1979676" cy="2103120"/>
           </a:xfrm>
           <a:prstGeom prst="roundRect">
             <a:avLst>
-              <a:gd name="adj" fmla="val 3765"/>
+              <a:gd name="adj" fmla="val 4619"/>
             </a:avLst>
           </a:prstGeom>
           <a:solidFill>
@@ -2278,14 +2299,36 @@
       </p:sp>
       <p:sp>
         <p:nvSpPr>
+          <p:cNvPr id="5" name="Shape 3"/>
+          <p:cNvSpPr/>
+          <p:nvPr/>
+        </p:nvSpPr>
+        <p:spPr>
+          <a:xfrm>
+            <a:off x="365760" y="1097280"/>
+            <a:ext cx="1979676" cy="502920"/>
+          </a:xfrm>
+          <a:prstGeom prst="roundRect">
+            <a:avLst>
+              <a:gd name="adj" fmla="val 18182"/>
+            </a:avLst>
+          </a:prstGeom>
+          <a:solidFill>
+            <a:srgbClr val="0E7C86"/>
+          </a:solidFill>
+          <a:ln/>
+        </p:spPr>
+      </p:sp>
+      <p:sp>
+        <p:nvSpPr>
           <p:cNvPr id="6" name="Shape 4"/>
           <p:cNvSpPr/>
           <p:nvPr/>
         </p:nvSpPr>
         <p:spPr>
           <a:xfrm>
-            <a:off x="411480" y="1280160"/>
-            <a:ext cx="1943100" cy="457200"/>
+            <a:off x="365760" y="1280160"/>
+            <a:ext cx="1979676" cy="320040"/>
           </a:xfrm>
           <a:prstGeom prst="rect">
             <a:avLst/>
@@ -2304,8 +2347,8 @@
         </p:nvSpPr>
         <p:spPr>
           <a:xfrm>
-            <a:off x="502920" y="1325880"/>
-            <a:ext cx="1760220" cy="365760"/>
+            <a:off x="493776" y="1170432"/>
+            <a:ext cx="1723644" cy="411480"/>
           </a:xfrm>
           <a:prstGeom prst="rect">
             <a:avLst/>
@@ -2321,7 +2364,7 @@
               <a:buNone/>
             </a:pPr>
             <a:r>
-              <a:rPr lang="en-US" sz="1400" b="1" dirty="0">
+              <a:rPr lang="en-US" sz="1300" b="1" dirty="0">
                 <a:solidFill>
                   <a:srgbClr val="FFFFFF"/>
                 </a:solidFill>
@@ -2331,7 +2374,7 @@
               </a:rPr>
               <a:t>Lovable</a:t>
             </a:r>
-            <a:endParaRPr lang="en-US" sz="1400" dirty="0"/>
+            <a:endParaRPr lang="en-US" sz="1300" dirty="0"/>
           </a:p>
         </p:txBody>
       </p:sp>
@@ -2343,8 +2386,8 @@
         </p:nvSpPr>
         <p:spPr>
           <a:xfrm>
-            <a:off x="548640" y="1874520"/>
-            <a:ext cx="1668780" cy="2377440"/>
+            <a:off x="530352" y="1719072"/>
+            <a:ext cx="1650492" cy="1389888"/>
           </a:xfrm>
           <a:prstGeom prst="rect">
             <a:avLst/>
@@ -2357,10 +2400,13 @@
           <a:lstStyle/>
           <a:p>
             <a:pPr indent="0" marL="0">
-              <a:buNone/>
-            </a:pPr>
-            <a:r>
-              <a:rPr lang="en-US" sz="1050" dirty="0">
+              <a:spcAft>
+                <a:spcPts val="200"/>
+              </a:spcAft>
+              <a:buNone/>
+            </a:pPr>
+            <a:r>
+              <a:rPr lang="en-US" sz="1100" dirty="0">
                 <a:solidFill>
                   <a:srgbClr val="1A1A1A"/>
                 </a:solidFill>
@@ -2370,7 +2416,7 @@
               </a:rPr>
               <a:t>AIに「こんなWebサイトが欲しい」と日本語で頼むだけでコードを書いてくれる、ノーコード生成ツール。</a:t>
             </a:r>
-            <a:endParaRPr lang="en-US" sz="1050" dirty="0"/>
+            <a:endParaRPr lang="en-US" sz="1100" dirty="0"/>
           </a:p>
         </p:txBody>
       </p:sp>
@@ -2382,12 +2428,12 @@
         </p:nvSpPr>
         <p:spPr>
           <a:xfrm>
-            <a:off x="2537460" y="1280160"/>
-            <a:ext cx="1943100" cy="3108960"/>
+            <a:off x="2510028" y="1097280"/>
+            <a:ext cx="1979676" cy="2103120"/>
           </a:xfrm>
           <a:prstGeom prst="roundRect">
             <a:avLst>
-              <a:gd name="adj" fmla="val 3765"/>
+              <a:gd name="adj" fmla="val 4619"/>
             </a:avLst>
           </a:prstGeom>
           <a:solidFill>
@@ -2395,7 +2441,7 @@
           </a:solidFill>
           <a:ln w="19050">
             <a:solidFill>
-              <a:srgbClr val="0E7C86"/>
+              <a:srgbClr val="E8A33D"/>
             </a:solidFill>
             <a:prstDash val="solid"/>
           </a:ln>
@@ -2409,28 +2455,50 @@
         </p:nvSpPr>
         <p:spPr>
           <a:xfrm>
-            <a:off x="2537460" y="1280160"/>
-            <a:ext cx="1943100" cy="457200"/>
-          </a:xfrm>
-          <a:prstGeom prst="rect">
-            <a:avLst/>
-          </a:prstGeom>
-          <a:solidFill>
-            <a:srgbClr val="0E7C86"/>
-          </a:solidFill>
-          <a:ln/>
-        </p:spPr>
-      </p:sp>
-      <p:sp>
-        <p:nvSpPr>
-          <p:cNvPr id="11" name="Text 9"/>
-          <p:cNvSpPr/>
-          <p:nvPr/>
-        </p:nvSpPr>
-        <p:spPr>
-          <a:xfrm>
-            <a:off x="2628900" y="1325880"/>
-            <a:ext cx="1760220" cy="365760"/>
+            <a:off x="2510028" y="1097280"/>
+            <a:ext cx="1979676" cy="502920"/>
+          </a:xfrm>
+          <a:prstGeom prst="roundRect">
+            <a:avLst>
+              <a:gd name="adj" fmla="val 18182"/>
+            </a:avLst>
+          </a:prstGeom>
+          <a:solidFill>
+            <a:srgbClr val="E8A33D"/>
+          </a:solidFill>
+          <a:ln/>
+        </p:spPr>
+      </p:sp>
+      <p:sp>
+        <p:nvSpPr>
+          <p:cNvPr id="11" name="Shape 9"/>
+          <p:cNvSpPr/>
+          <p:nvPr/>
+        </p:nvSpPr>
+        <p:spPr>
+          <a:xfrm>
+            <a:off x="2510028" y="1280160"/>
+            <a:ext cx="1979676" cy="320040"/>
+          </a:xfrm>
+          <a:prstGeom prst="rect">
+            <a:avLst/>
+          </a:prstGeom>
+          <a:solidFill>
+            <a:srgbClr val="E8A33D"/>
+          </a:solidFill>
+          <a:ln/>
+        </p:spPr>
+      </p:sp>
+      <p:sp>
+        <p:nvSpPr>
+          <p:cNvPr id="12" name="Text 10"/>
+          <p:cNvSpPr/>
+          <p:nvPr/>
+        </p:nvSpPr>
+        <p:spPr>
+          <a:xfrm>
+            <a:off x="2638044" y="1170432"/>
+            <a:ext cx="1723644" cy="411480"/>
           </a:xfrm>
           <a:prstGeom prst="rect">
             <a:avLst/>
@@ -2446,7 +2514,7 @@
               <a:buNone/>
             </a:pPr>
             <a:r>
-              <a:rPr lang="en-US" sz="1400" b="1" dirty="0">
+              <a:rPr lang="en-US" sz="1300" b="1" dirty="0">
                 <a:solidFill>
                   <a:srgbClr val="FFFFFF"/>
                 </a:solidFill>
@@ -2456,20 +2524,20 @@
               </a:rPr>
               <a:t>LP（ランディングページ）</a:t>
             </a:r>
-            <a:endParaRPr lang="en-US" sz="1400" dirty="0"/>
-          </a:p>
-        </p:txBody>
-      </p:sp>
-      <p:sp>
-        <p:nvSpPr>
-          <p:cNvPr id="12" name="Text 10"/>
-          <p:cNvSpPr/>
-          <p:nvPr/>
-        </p:nvSpPr>
-        <p:spPr>
-          <a:xfrm>
-            <a:off x="2674620" y="1874520"/>
-            <a:ext cx="1668780" cy="2377440"/>
+            <a:endParaRPr lang="en-US" sz="1300" dirty="0"/>
+          </a:p>
+        </p:txBody>
+      </p:sp>
+      <p:sp>
+        <p:nvSpPr>
+          <p:cNvPr id="13" name="Text 11"/>
+          <p:cNvSpPr/>
+          <p:nvPr/>
+        </p:nvSpPr>
+        <p:spPr>
+          <a:xfrm>
+            <a:off x="2674620" y="1719072"/>
+            <a:ext cx="1650492" cy="1389888"/>
           </a:xfrm>
           <a:prstGeom prst="rect">
             <a:avLst/>
@@ -2482,10 +2550,13 @@
           <a:lstStyle/>
           <a:p>
             <a:pPr indent="0" marL="0">
-              <a:buNone/>
-            </a:pPr>
-            <a:r>
-              <a:rPr lang="en-US" sz="1050" dirty="0">
+              <a:spcAft>
+                <a:spcPts val="200"/>
+              </a:spcAft>
+              <a:buNone/>
+            </a:pPr>
+            <a:r>
+              <a:rPr lang="en-US" sz="1100" dirty="0">
                 <a:solidFill>
                   <a:srgbClr val="1A1A1A"/>
                 </a:solidFill>
@@ -2495,24 +2566,24 @@
               </a:rPr>
               <a:t>SNS や広告から訪れた人が「最初に着地する」1ページのサイト。商談予約や登録の入口にする。</a:t>
             </a:r>
-            <a:endParaRPr lang="en-US" sz="1050" dirty="0"/>
-          </a:p>
-        </p:txBody>
-      </p:sp>
-      <p:sp>
-        <p:nvSpPr>
-          <p:cNvPr id="13" name="Shape 11"/>
-          <p:cNvSpPr/>
-          <p:nvPr/>
-        </p:nvSpPr>
-        <p:spPr>
-          <a:xfrm>
-            <a:off x="4663440" y="1280160"/>
-            <a:ext cx="1943100" cy="3108960"/>
+            <a:endParaRPr lang="en-US" sz="1100" dirty="0"/>
+          </a:p>
+        </p:txBody>
+      </p:sp>
+      <p:sp>
+        <p:nvSpPr>
+          <p:cNvPr id="14" name="Shape 12"/>
+          <p:cNvSpPr/>
+          <p:nvPr/>
+        </p:nvSpPr>
+        <p:spPr>
+          <a:xfrm>
+            <a:off x="4654296" y="1097280"/>
+            <a:ext cx="1979676" cy="2103120"/>
           </a:xfrm>
           <a:prstGeom prst="roundRect">
             <a:avLst>
-              <a:gd name="adj" fmla="val 3765"/>
+              <a:gd name="adj" fmla="val 4619"/>
             </a:avLst>
           </a:prstGeom>
           <a:solidFill>
@@ -2520,7 +2591,7 @@
           </a:solidFill>
           <a:ln w="19050">
             <a:solidFill>
-              <a:srgbClr val="0E7C86"/>
+              <a:srgbClr val="1F3A5F"/>
             </a:solidFill>
             <a:prstDash val="solid"/>
           </a:ln>
@@ -2528,34 +2599,56 @@
       </p:sp>
       <p:sp>
         <p:nvSpPr>
-          <p:cNvPr id="14" name="Shape 12"/>
-          <p:cNvSpPr/>
-          <p:nvPr/>
-        </p:nvSpPr>
-        <p:spPr>
-          <a:xfrm>
-            <a:off x="4663440" y="1280160"/>
-            <a:ext cx="1943100" cy="457200"/>
-          </a:xfrm>
-          <a:prstGeom prst="rect">
-            <a:avLst/>
-          </a:prstGeom>
-          <a:solidFill>
-            <a:srgbClr val="0E7C86"/>
-          </a:solidFill>
-          <a:ln/>
-        </p:spPr>
-      </p:sp>
-      <p:sp>
-        <p:nvSpPr>
-          <p:cNvPr id="15" name="Text 13"/>
-          <p:cNvSpPr/>
-          <p:nvPr/>
-        </p:nvSpPr>
-        <p:spPr>
-          <a:xfrm>
-            <a:off x="4754880" y="1325880"/>
-            <a:ext cx="1760220" cy="365760"/>
+          <p:cNvPr id="15" name="Shape 13"/>
+          <p:cNvSpPr/>
+          <p:nvPr/>
+        </p:nvSpPr>
+        <p:spPr>
+          <a:xfrm>
+            <a:off x="4654296" y="1097280"/>
+            <a:ext cx="1979676" cy="502920"/>
+          </a:xfrm>
+          <a:prstGeom prst="roundRect">
+            <a:avLst>
+              <a:gd name="adj" fmla="val 18182"/>
+            </a:avLst>
+          </a:prstGeom>
+          <a:solidFill>
+            <a:srgbClr val="1F3A5F"/>
+          </a:solidFill>
+          <a:ln/>
+        </p:spPr>
+      </p:sp>
+      <p:sp>
+        <p:nvSpPr>
+          <p:cNvPr id="16" name="Shape 14"/>
+          <p:cNvSpPr/>
+          <p:nvPr/>
+        </p:nvSpPr>
+        <p:spPr>
+          <a:xfrm>
+            <a:off x="4654296" y="1280160"/>
+            <a:ext cx="1979676" cy="320040"/>
+          </a:xfrm>
+          <a:prstGeom prst="rect">
+            <a:avLst/>
+          </a:prstGeom>
+          <a:solidFill>
+            <a:srgbClr val="1F3A5F"/>
+          </a:solidFill>
+          <a:ln/>
+        </p:spPr>
+      </p:sp>
+      <p:sp>
+        <p:nvSpPr>
+          <p:cNvPr id="17" name="Text 15"/>
+          <p:cNvSpPr/>
+          <p:nvPr/>
+        </p:nvSpPr>
+        <p:spPr>
+          <a:xfrm>
+            <a:off x="4782312" y="1170432"/>
+            <a:ext cx="1723644" cy="411480"/>
           </a:xfrm>
           <a:prstGeom prst="rect">
             <a:avLst/>
@@ -2571,7 +2664,7 @@
               <a:buNone/>
             </a:pPr>
             <a:r>
-              <a:rPr lang="en-US" sz="1400" b="1" dirty="0">
+              <a:rPr lang="en-US" sz="1300" b="1" dirty="0">
                 <a:solidFill>
                   <a:srgbClr val="FFFFFF"/>
                 </a:solidFill>
@@ -2581,20 +2674,20 @@
               </a:rPr>
               <a:t>バイブコーディング</a:t>
             </a:r>
-            <a:endParaRPr lang="en-US" sz="1400" dirty="0"/>
-          </a:p>
-        </p:txBody>
-      </p:sp>
-      <p:sp>
-        <p:nvSpPr>
-          <p:cNvPr id="16" name="Text 14"/>
-          <p:cNvSpPr/>
-          <p:nvPr/>
-        </p:nvSpPr>
-        <p:spPr>
-          <a:xfrm>
-            <a:off x="4800600" y="1874520"/>
-            <a:ext cx="1668780" cy="2377440"/>
+            <a:endParaRPr lang="en-US" sz="1300" dirty="0"/>
+          </a:p>
+        </p:txBody>
+      </p:sp>
+      <p:sp>
+        <p:nvSpPr>
+          <p:cNvPr id="18" name="Text 16"/>
+          <p:cNvSpPr/>
+          <p:nvPr/>
+        </p:nvSpPr>
+        <p:spPr>
+          <a:xfrm>
+            <a:off x="4818888" y="1719072"/>
+            <a:ext cx="1650492" cy="1389888"/>
           </a:xfrm>
           <a:prstGeom prst="rect">
             <a:avLst/>
@@ -2607,10 +2700,13 @@
           <a:lstStyle/>
           <a:p>
             <a:pPr indent="0" marL="0">
-              <a:buNone/>
-            </a:pPr>
-            <a:r>
-              <a:rPr lang="en-US" sz="1050" dirty="0">
+              <a:spcAft>
+                <a:spcPts val="200"/>
+              </a:spcAft>
+              <a:buNone/>
+            </a:pPr>
+            <a:r>
+              <a:rPr lang="en-US" sz="1100" dirty="0">
                 <a:solidFill>
                   <a:srgbClr val="1A1A1A"/>
                 </a:solidFill>
@@ -2620,24 +2716,24 @@
               </a:rPr>
               <a:t>コードを書かず、日本語でやりたいことを AI に伝えて修正を重ねながら形にする作り方。</a:t>
             </a:r>
-            <a:endParaRPr lang="en-US" sz="1050" dirty="0"/>
-          </a:p>
-        </p:txBody>
-      </p:sp>
-      <p:sp>
-        <p:nvSpPr>
-          <p:cNvPr id="17" name="Shape 15"/>
-          <p:cNvSpPr/>
-          <p:nvPr/>
-        </p:nvSpPr>
-        <p:spPr>
-          <a:xfrm>
-            <a:off x="6789420" y="1280160"/>
-            <a:ext cx="1943100" cy="3108960"/>
+            <a:endParaRPr lang="en-US" sz="1100" dirty="0"/>
+          </a:p>
+        </p:txBody>
+      </p:sp>
+      <p:sp>
+        <p:nvSpPr>
+          <p:cNvPr id="19" name="Shape 17"/>
+          <p:cNvSpPr/>
+          <p:nvPr/>
+        </p:nvSpPr>
+        <p:spPr>
+          <a:xfrm>
+            <a:off x="6798564" y="1097280"/>
+            <a:ext cx="1979676" cy="2103120"/>
           </a:xfrm>
           <a:prstGeom prst="roundRect">
             <a:avLst>
-              <a:gd name="adj" fmla="val 3765"/>
+              <a:gd name="adj" fmla="val 4619"/>
             </a:avLst>
           </a:prstGeom>
           <a:solidFill>
@@ -2645,7 +2741,7 @@
           </a:solidFill>
           <a:ln w="19050">
             <a:solidFill>
-              <a:srgbClr val="0E7C86"/>
+              <a:srgbClr val="7C5F8A"/>
             </a:solidFill>
             <a:prstDash val="solid"/>
           </a:ln>
@@ -2653,34 +2749,56 @@
       </p:sp>
       <p:sp>
         <p:nvSpPr>
-          <p:cNvPr id="18" name="Shape 16"/>
-          <p:cNvSpPr/>
-          <p:nvPr/>
-        </p:nvSpPr>
-        <p:spPr>
-          <a:xfrm>
-            <a:off x="6789420" y="1280160"/>
-            <a:ext cx="1943100" cy="457200"/>
-          </a:xfrm>
-          <a:prstGeom prst="rect">
-            <a:avLst/>
-          </a:prstGeom>
-          <a:solidFill>
-            <a:srgbClr val="0E7C86"/>
-          </a:solidFill>
-          <a:ln/>
-        </p:spPr>
-      </p:sp>
-      <p:sp>
-        <p:nvSpPr>
-          <p:cNvPr id="19" name="Text 17"/>
-          <p:cNvSpPr/>
-          <p:nvPr/>
-        </p:nvSpPr>
-        <p:spPr>
-          <a:xfrm>
-            <a:off x="6880860" y="1325880"/>
-            <a:ext cx="1760220" cy="365760"/>
+          <p:cNvPr id="20" name="Shape 18"/>
+          <p:cNvSpPr/>
+          <p:nvPr/>
+        </p:nvSpPr>
+        <p:spPr>
+          <a:xfrm>
+            <a:off x="6798564" y="1097280"/>
+            <a:ext cx="1979676" cy="502920"/>
+          </a:xfrm>
+          <a:prstGeom prst="roundRect">
+            <a:avLst>
+              <a:gd name="adj" fmla="val 18182"/>
+            </a:avLst>
+          </a:prstGeom>
+          <a:solidFill>
+            <a:srgbClr val="7C5F8A"/>
+          </a:solidFill>
+          <a:ln/>
+        </p:spPr>
+      </p:sp>
+      <p:sp>
+        <p:nvSpPr>
+          <p:cNvPr id="21" name="Shape 19"/>
+          <p:cNvSpPr/>
+          <p:nvPr/>
+        </p:nvSpPr>
+        <p:spPr>
+          <a:xfrm>
+            <a:off x="6798564" y="1280160"/>
+            <a:ext cx="1979676" cy="320040"/>
+          </a:xfrm>
+          <a:prstGeom prst="rect">
+            <a:avLst/>
+          </a:prstGeom>
+          <a:solidFill>
+            <a:srgbClr val="7C5F8A"/>
+          </a:solidFill>
+          <a:ln/>
+        </p:spPr>
+      </p:sp>
+      <p:sp>
+        <p:nvSpPr>
+          <p:cNvPr id="22" name="Text 20"/>
+          <p:cNvSpPr/>
+          <p:nvPr/>
+        </p:nvSpPr>
+        <p:spPr>
+          <a:xfrm>
+            <a:off x="6926580" y="1170432"/>
+            <a:ext cx="1723644" cy="411480"/>
           </a:xfrm>
           <a:prstGeom prst="rect">
             <a:avLst/>
@@ -2696,7 +2814,7 @@
               <a:buNone/>
             </a:pPr>
             <a:r>
-              <a:rPr lang="en-US" sz="1400" b="1" dirty="0">
+              <a:rPr lang="en-US" sz="1300" b="1" dirty="0">
                 <a:solidFill>
                   <a:srgbClr val="FFFFFF"/>
                 </a:solidFill>
@@ -2706,20 +2824,20 @@
               </a:rPr>
               <a:t>CTA（行動喚起）</a:t>
             </a:r>
-            <a:endParaRPr lang="en-US" sz="1400" dirty="0"/>
-          </a:p>
-        </p:txBody>
-      </p:sp>
-      <p:sp>
-        <p:nvSpPr>
-          <p:cNvPr id="20" name="Text 18"/>
-          <p:cNvSpPr/>
-          <p:nvPr/>
-        </p:nvSpPr>
-        <p:spPr>
-          <a:xfrm>
-            <a:off x="6926580" y="1874520"/>
-            <a:ext cx="1668780" cy="2377440"/>
+            <a:endParaRPr lang="en-US" sz="1300" dirty="0"/>
+          </a:p>
+        </p:txBody>
+      </p:sp>
+      <p:sp>
+        <p:nvSpPr>
+          <p:cNvPr id="23" name="Text 21"/>
+          <p:cNvSpPr/>
+          <p:nvPr/>
+        </p:nvSpPr>
+        <p:spPr>
+          <a:xfrm>
+            <a:off x="6963156" y="1719072"/>
+            <a:ext cx="1650492" cy="1389888"/>
           </a:xfrm>
           <a:prstGeom prst="rect">
             <a:avLst/>
@@ -2732,10 +2850,13 @@
           <a:lstStyle/>
           <a:p>
             <a:pPr indent="0" marL="0">
-              <a:buNone/>
-            </a:pPr>
-            <a:r>
-              <a:rPr lang="en-US" sz="1050" dirty="0">
+              <a:spcAft>
+                <a:spcPts val="200"/>
+              </a:spcAft>
+              <a:buNone/>
+            </a:pPr>
+            <a:r>
+              <a:rPr lang="en-US" sz="1100" dirty="0">
                 <a:solidFill>
                   <a:srgbClr val="1A1A1A"/>
                 </a:solidFill>
@@ -2745,46 +2866,200 @@
               </a:rPr>
               <a:t>「公式LINE登録」「予約する」など、訪問者にして欲しい行動を促すボタンや文言。</a:t>
             </a:r>
-            <a:endParaRPr lang="en-US" sz="1050" dirty="0"/>
-          </a:p>
-        </p:txBody>
-      </p:sp>
-      <p:sp>
-        <p:nvSpPr>
-          <p:cNvPr id="21" name="Text 19"/>
-          <p:cNvSpPr/>
-          <p:nvPr/>
-        </p:nvSpPr>
-        <p:spPr>
-          <a:xfrm>
-            <a:off x="411480" y="4663440"/>
-            <a:ext cx="8321040" cy="320040"/>
-          </a:xfrm>
-          <a:prstGeom prst="rect">
-            <a:avLst/>
-          </a:prstGeom>
-          <a:noFill/>
-          <a:ln/>
-        </p:spPr>
-        <p:txBody>
-          <a:bodyPr wrap="square" rtlCol="0" anchor="ctr"/>
-          <a:lstStyle/>
-          <a:p>
-            <a:pPr indent="0" marL="0">
-              <a:buNone/>
-            </a:pPr>
-            <a:r>
-              <a:rPr lang="en-US" sz="900" i="1" dirty="0">
-                <a:solidFill>
-                  <a:srgbClr val="555555"/>
+            <a:endParaRPr lang="en-US" sz="1100" dirty="0"/>
+          </a:p>
+        </p:txBody>
+      </p:sp>
+      <p:sp>
+        <p:nvSpPr>
+          <p:cNvPr id="24" name="Text 22"/>
+          <p:cNvSpPr/>
+          <p:nvPr/>
+        </p:nvSpPr>
+        <p:spPr>
+          <a:xfrm>
+            <a:off x="365760" y="3703320"/>
+            <a:ext cx="8412480" cy="1188720"/>
+          </a:xfrm>
+          <a:prstGeom prst="rect">
+            <a:avLst/>
+          </a:prstGeom>
+          <a:noFill/>
+          <a:ln/>
+        </p:spPr>
+        <p:txBody>
+          <a:bodyPr wrap="square" rtlCol="0" anchor="t"/>
+          <a:lstStyle/>
+          <a:p>
+            <a:pPr indent="0" marL="0">
+              <a:buNone/>
+            </a:pPr>
+            <a:r>
+              <a:rPr lang="en-US" sz="950" b="1" dirty="0">
+                <a:solidFill>
+                  <a:srgbClr val="E8A33D"/>
                 </a:solidFill>
                 <a:latin typeface="Yu Gothic UI" pitchFamily="34" charset="0"/>
                 <a:ea typeface="Yu Gothic UI" pitchFamily="34" charset="-122"/>
                 <a:cs typeface="Yu Gothic UI" pitchFamily="34" charset="-120"/>
               </a:rPr>
-              <a:t>※ Lovable: ブラウザだけで使え、無料枠あり。生成結果は自分のドメインで公開可能   ※ LP（ランディングページ）: ホームページとの違いは「1つの行動」だけを促す設計のこと   ※ バイブコーディング: 空気感(vibe)で指示するスタイル   ※ CTA（行動喚起）: Call To Action の略</a:t>
-            </a:r>
-            <a:endParaRPr lang="en-US" sz="900" dirty="0"/>
+              <a:t>※ </a:t>
+            </a:r>
+            <a:pPr indent="0" marL="0">
+              <a:buNone/>
+            </a:pPr>
+            <a:r>
+              <a:rPr lang="en-US" sz="950" b="1" dirty="0">
+                <a:solidFill>
+                  <a:srgbClr val="1F3A5F"/>
+                </a:solidFill>
+                <a:latin typeface="Yu Gothic UI" pitchFamily="34" charset="0"/>
+                <a:ea typeface="Yu Gothic UI" pitchFamily="34" charset="-122"/>
+                <a:cs typeface="Yu Gothic UI" pitchFamily="34" charset="-120"/>
+              </a:rPr>
+              <a:t>Lovable: </a:t>
+            </a:r>
+            <a:pPr indent="0" marL="0">
+              <a:buNone/>
+            </a:pPr>
+            <a:r>
+              <a:rPr lang="en-US" sz="950" dirty="0">
+                <a:solidFill>
+                  <a:srgbClr val="555555"/>
+                </a:solidFill>
+                <a:latin typeface="Yu Gothic UI" pitchFamily="34" charset="0"/>
+                <a:ea typeface="Yu Gothic UI" pitchFamily="34" charset="-122"/>
+                <a:cs typeface="Yu Gothic UI" pitchFamily="34" charset="-120"/>
+              </a:rPr>
+              <a:t>ブラウザだけで使え、無料枠あり。生成結果は自分のドメインで公開可能   </a:t>
+            </a:r>
+            <a:pPr indent="0" marL="0">
+              <a:buNone/>
+            </a:pPr>
+            <a:r>
+              <a:rPr lang="en-US" sz="950" b="1" dirty="0">
+                <a:solidFill>
+                  <a:srgbClr val="E8A33D"/>
+                </a:solidFill>
+                <a:latin typeface="Yu Gothic UI" pitchFamily="34" charset="0"/>
+                <a:ea typeface="Yu Gothic UI" pitchFamily="34" charset="-122"/>
+                <a:cs typeface="Yu Gothic UI" pitchFamily="34" charset="-120"/>
+              </a:rPr>
+              <a:t>※ </a:t>
+            </a:r>
+            <a:pPr indent="0" marL="0">
+              <a:buNone/>
+            </a:pPr>
+            <a:r>
+              <a:rPr lang="en-US" sz="950" b="1" dirty="0">
+                <a:solidFill>
+                  <a:srgbClr val="1F3A5F"/>
+                </a:solidFill>
+                <a:latin typeface="Yu Gothic UI" pitchFamily="34" charset="0"/>
+                <a:ea typeface="Yu Gothic UI" pitchFamily="34" charset="-122"/>
+                <a:cs typeface="Yu Gothic UI" pitchFamily="34" charset="-120"/>
+              </a:rPr>
+              <a:t>LP（ランディングページ）: </a:t>
+            </a:r>
+            <a:pPr indent="0" marL="0">
+              <a:buNone/>
+            </a:pPr>
+            <a:r>
+              <a:rPr lang="en-US" sz="950" dirty="0">
+                <a:solidFill>
+                  <a:srgbClr val="555555"/>
+                </a:solidFill>
+                <a:latin typeface="Yu Gothic UI" pitchFamily="34" charset="0"/>
+                <a:ea typeface="Yu Gothic UI" pitchFamily="34" charset="-122"/>
+                <a:cs typeface="Yu Gothic UI" pitchFamily="34" charset="-120"/>
+              </a:rPr>
+              <a:t>ホームページとの違いは「1つの行動」だけを促す設計のこと   </a:t>
+            </a:r>
+            <a:pPr indent="0" marL="0">
+              <a:buNone/>
+            </a:pPr>
+            <a:r>
+              <a:rPr lang="en-US" sz="950" b="1" dirty="0">
+                <a:solidFill>
+                  <a:srgbClr val="E8A33D"/>
+                </a:solidFill>
+                <a:latin typeface="Yu Gothic UI" pitchFamily="34" charset="0"/>
+                <a:ea typeface="Yu Gothic UI" pitchFamily="34" charset="-122"/>
+                <a:cs typeface="Yu Gothic UI" pitchFamily="34" charset="-120"/>
+              </a:rPr>
+              <a:t>※ </a:t>
+            </a:r>
+            <a:pPr indent="0" marL="0">
+              <a:buNone/>
+            </a:pPr>
+            <a:r>
+              <a:rPr lang="en-US" sz="950" b="1" dirty="0">
+                <a:solidFill>
+                  <a:srgbClr val="1F3A5F"/>
+                </a:solidFill>
+                <a:latin typeface="Yu Gothic UI" pitchFamily="34" charset="0"/>
+                <a:ea typeface="Yu Gothic UI" pitchFamily="34" charset="-122"/>
+                <a:cs typeface="Yu Gothic UI" pitchFamily="34" charset="-120"/>
+              </a:rPr>
+              <a:t>バイブコーディング: </a:t>
+            </a:r>
+            <a:pPr indent="0" marL="0">
+              <a:buNone/>
+            </a:pPr>
+            <a:r>
+              <a:rPr lang="en-US" sz="950" dirty="0">
+                <a:solidFill>
+                  <a:srgbClr val="555555"/>
+                </a:solidFill>
+                <a:latin typeface="Yu Gothic UI" pitchFamily="34" charset="0"/>
+                <a:ea typeface="Yu Gothic UI" pitchFamily="34" charset="-122"/>
+                <a:cs typeface="Yu Gothic UI" pitchFamily="34" charset="-120"/>
+              </a:rPr>
+              <a:t>空気感(vibe)で指示するスタイル   </a:t>
+            </a:r>
+            <a:pPr indent="0" marL="0">
+              <a:buNone/>
+            </a:pPr>
+            <a:r>
+              <a:rPr lang="en-US" sz="950" b="1" dirty="0">
+                <a:solidFill>
+                  <a:srgbClr val="E8A33D"/>
+                </a:solidFill>
+                <a:latin typeface="Yu Gothic UI" pitchFamily="34" charset="0"/>
+                <a:ea typeface="Yu Gothic UI" pitchFamily="34" charset="-122"/>
+                <a:cs typeface="Yu Gothic UI" pitchFamily="34" charset="-120"/>
+              </a:rPr>
+              <a:t>※ </a:t>
+            </a:r>
+            <a:pPr indent="0" marL="0">
+              <a:buNone/>
+            </a:pPr>
+            <a:r>
+              <a:rPr lang="en-US" sz="950" b="1" dirty="0">
+                <a:solidFill>
+                  <a:srgbClr val="1F3A5F"/>
+                </a:solidFill>
+                <a:latin typeface="Yu Gothic UI" pitchFamily="34" charset="0"/>
+                <a:ea typeface="Yu Gothic UI" pitchFamily="34" charset="-122"/>
+                <a:cs typeface="Yu Gothic UI" pitchFamily="34" charset="-120"/>
+              </a:rPr>
+              <a:t>CTA（行動喚起）: </a:t>
+            </a:r>
+            <a:pPr indent="0" marL="0">
+              <a:buNone/>
+            </a:pPr>
+            <a:r>
+              <a:rPr lang="en-US" sz="950" dirty="0">
+                <a:solidFill>
+                  <a:srgbClr val="555555"/>
+                </a:solidFill>
+                <a:latin typeface="Yu Gothic UI" pitchFamily="34" charset="0"/>
+                <a:ea typeface="Yu Gothic UI" pitchFamily="34" charset="-122"/>
+                <a:cs typeface="Yu Gothic UI" pitchFamily="34" charset="-120"/>
+              </a:rPr>
+              <a:t>Call To Action の略   </a:t>
+            </a:r>
+            <a:endParaRPr lang="en-US" sz="950" dirty="0"/>
           </a:p>
         </p:txBody>
       </p:sp>
@@ -3535,7 +3810,7 @@
                 <a:ea typeface="Yu Gothic UI" pitchFamily="34" charset="-122"/>
                 <a:cs typeface="Yu Gothic UI" pitchFamily="34" charset="-120"/>
               </a:rPr>
-              <a:t>プロンプトをさらにブラッシュアップ</a:t>
+              <a:t>プロンプトをさらにブラッシュアップ — 3観点でセルフチェック</a:t>
             </a:r>
             <a:endParaRPr lang="en-US" sz="1300" dirty="0"/>
           </a:p>
@@ -3550,19 +3825,19 @@
         <p:spPr>
           <a:xfrm>
             <a:off x="411480" y="1188720"/>
-            <a:ext cx="2651760" cy="3520440"/>
+            <a:ext cx="2651760" cy="3291840"/>
           </a:xfrm>
           <a:prstGeom prst="roundRect">
             <a:avLst>
-              <a:gd name="adj" fmla="val 2759"/>
+              <a:gd name="adj" fmla="val 3448"/>
             </a:avLst>
           </a:prstGeom>
           <a:solidFill>
             <a:srgbClr val="F4F6F9"/>
           </a:solidFill>
-          <a:ln w="6350">
+          <a:ln w="15240">
             <a:solidFill>
-              <a:srgbClr val="D7DCE3"/>
+              <a:srgbClr val="0E7C86"/>
             </a:solidFill>
             <a:prstDash val="solid"/>
           </a:ln>
@@ -3577,7 +3852,7 @@
         <p:spPr>
           <a:xfrm>
             <a:off x="411480" y="1188720"/>
-            <a:ext cx="2651760" cy="411480"/>
+            <a:ext cx="2651760" cy="384048"/>
           </a:xfrm>
           <a:prstGeom prst="rect">
             <a:avLst/>
@@ -3596,8 +3871,8 @@
         </p:nvSpPr>
         <p:spPr>
           <a:xfrm>
-            <a:off x="502920" y="1225296"/>
-            <a:ext cx="2468880" cy="329184"/>
+            <a:off x="521208" y="1225296"/>
+            <a:ext cx="2432304" cy="310896"/>
           </a:xfrm>
           <a:prstGeom prst="rect">
             <a:avLst/>
@@ -3635,7 +3910,7 @@
         </p:nvSpPr>
         <p:spPr>
           <a:xfrm>
-            <a:off x="576072" y="1691640"/>
+            <a:off x="576072" y="1645920"/>
             <a:ext cx="2377440" cy="457200"/>
           </a:xfrm>
           <a:prstGeom prst="rect">
@@ -3652,7 +3927,7 @@
               <a:buNone/>
             </a:pPr>
             <a:r>
-              <a:rPr lang="en-US" sz="1250" b="1" dirty="0">
+              <a:rPr lang="en-US" sz="1200" b="1" dirty="0">
                 <a:solidFill>
                   <a:srgbClr val="1F3A5F"/>
                 </a:solidFill>
@@ -3662,7 +3937,7 @@
               </a:rPr>
               <a:t>A. ターゲット解像度</a:t>
             </a:r>
-            <a:endParaRPr lang="en-US" sz="1250" dirty="0"/>
+            <a:endParaRPr lang="en-US" sz="1200" dirty="0"/>
           </a:p>
         </p:txBody>
       </p:sp>
@@ -3674,8 +3949,8 @@
         </p:nvSpPr>
         <p:spPr>
           <a:xfrm>
-            <a:off x="576072" y="2194560"/>
-            <a:ext cx="2377440" cy="1097280"/>
+            <a:off x="576072" y="2148840"/>
+            <a:ext cx="2377440" cy="1051560"/>
           </a:xfrm>
           <a:prstGeom prst="rect">
             <a:avLst/>
@@ -3691,7 +3966,7 @@
               <a:buNone/>
             </a:pPr>
             <a:r>
-              <a:rPr lang="en-US" sz="1100" b="1" dirty="0">
+              <a:rPr lang="en-US" sz="1200" b="1" dirty="0">
                 <a:solidFill>
                   <a:srgbClr val="0E7C86"/>
                 </a:solidFill>
@@ -3699,13 +3974,13 @@
                 <a:ea typeface="Yu Gothic UI" pitchFamily="34" charset="-122"/>
                 <a:cs typeface="Yu Gothic UI" pitchFamily="34" charset="-120"/>
               </a:rPr>
-              <a:t>✓ </a:t>
-            </a:r>
-            <a:pPr indent="0" marL="0">
-              <a:buNone/>
-            </a:pPr>
-            <a:r>
-              <a:rPr lang="en-US" sz="1100" dirty="0">
+              <a:t>✓  </a:t>
+            </a:r>
+            <a:pPr indent="0" marL="0">
+              <a:buNone/>
+            </a:pPr>
+            <a:r>
+              <a:rPr lang="en-US" sz="1050" dirty="0">
                 <a:solidFill>
                   <a:srgbClr val="1A1A1A"/>
                 </a:solidFill>
@@ -3715,7 +3990,7 @@
               </a:rPr>
               <a:t>プロンプトに「誰の・どんな悩み・どんな状況」が一文で書けたか</a:t>
             </a:r>
-            <a:endParaRPr lang="en-US" sz="1100" dirty="0"/>
+            <a:endParaRPr lang="en-US" sz="1050" dirty="0"/>
           </a:p>
         </p:txBody>
       </p:sp>
@@ -3727,7 +4002,7 @@
         </p:nvSpPr>
         <p:spPr>
           <a:xfrm>
-            <a:off x="576072" y="3383280"/>
+            <a:off x="576072" y="3200400"/>
             <a:ext cx="2377440" cy="1188720"/>
           </a:xfrm>
           <a:prstGeom prst="rect">
@@ -3744,7 +4019,7 @@
               <a:buNone/>
             </a:pPr>
             <a:r>
-              <a:rPr lang="en-US" sz="1100" b="1" dirty="0">
+              <a:rPr lang="en-US" sz="1200" b="1" dirty="0">
                 <a:solidFill>
                   <a:srgbClr val="E8A33D"/>
                 </a:solidFill>
@@ -3752,13 +4027,13 @@
                 <a:ea typeface="Yu Gothic UI" pitchFamily="34" charset="-122"/>
                 <a:cs typeface="Yu Gothic UI" pitchFamily="34" charset="-120"/>
               </a:rPr>
-              <a:t>💡 </a:t>
-            </a:r>
-            <a:pPr indent="0" marL="0">
-              <a:buNone/>
-            </a:pPr>
-            <a:r>
-              <a:rPr lang="en-US" sz="1100" dirty="0">
+              <a:t>💡  </a:t>
+            </a:r>
+            <a:pPr indent="0" marL="0">
+              <a:buNone/>
+            </a:pPr>
+            <a:r>
+              <a:rPr lang="en-US" sz="1050" dirty="0">
                 <a:solidFill>
                   <a:srgbClr val="1A1A1A"/>
                 </a:solidFill>
@@ -3768,7 +4043,7 @@
               </a:rPr>
               <a:t>「家族の保障を見直したい30代共働き世帯」など、属性+悩み+状況の3要素で書かせる</a:t>
             </a:r>
-            <a:endParaRPr lang="en-US" sz="1100" dirty="0"/>
+            <a:endParaRPr lang="en-US" sz="1050" dirty="0"/>
           </a:p>
         </p:txBody>
       </p:sp>
@@ -3781,19 +4056,19 @@
         <p:spPr>
           <a:xfrm>
             <a:off x="3246120" y="1188720"/>
-            <a:ext cx="2651760" cy="3520440"/>
+            <a:ext cx="2651760" cy="3291840"/>
           </a:xfrm>
           <a:prstGeom prst="roundRect">
             <a:avLst>
-              <a:gd name="adj" fmla="val 2759"/>
+              <a:gd name="adj" fmla="val 3448"/>
             </a:avLst>
           </a:prstGeom>
           <a:solidFill>
             <a:srgbClr val="F4F6F9"/>
           </a:solidFill>
-          <a:ln w="6350">
+          <a:ln w="15240">
             <a:solidFill>
-              <a:srgbClr val="D7DCE3"/>
+              <a:srgbClr val="E8A33D"/>
             </a:solidFill>
             <a:prstDash val="solid"/>
           </a:ln>
@@ -3808,13 +4083,13 @@
         <p:spPr>
           <a:xfrm>
             <a:off x="3246120" y="1188720"/>
-            <a:ext cx="2651760" cy="411480"/>
-          </a:xfrm>
-          <a:prstGeom prst="rect">
-            <a:avLst/>
-          </a:prstGeom>
-          <a:solidFill>
-            <a:srgbClr val="0E7C86"/>
+            <a:ext cx="2651760" cy="384048"/>
+          </a:xfrm>
+          <a:prstGeom prst="rect">
+            <a:avLst/>
+          </a:prstGeom>
+          <a:solidFill>
+            <a:srgbClr val="E8A33D"/>
           </a:solidFill>
           <a:ln/>
         </p:spPr>
@@ -3827,8 +4102,8 @@
         </p:nvSpPr>
         <p:spPr>
           <a:xfrm>
-            <a:off x="3337560" y="1225296"/>
-            <a:ext cx="2468880" cy="329184"/>
+            <a:off x="3355848" y="1225296"/>
+            <a:ext cx="2432304" cy="310896"/>
           </a:xfrm>
           <a:prstGeom prst="rect">
             <a:avLst/>
@@ -3866,7 +4141,7 @@
         </p:nvSpPr>
         <p:spPr>
           <a:xfrm>
-            <a:off x="3410712" y="1691640"/>
+            <a:off x="3410712" y="1645920"/>
             <a:ext cx="2377440" cy="457200"/>
           </a:xfrm>
           <a:prstGeom prst="rect">
@@ -3883,7 +4158,7 @@
               <a:buNone/>
             </a:pPr>
             <a:r>
-              <a:rPr lang="en-US" sz="1250" b="1" dirty="0">
+              <a:rPr lang="en-US" sz="1200" b="1" dirty="0">
                 <a:solidFill>
                   <a:srgbClr val="1F3A5F"/>
                 </a:solidFill>
@@ -3893,7 +4168,7 @@
               </a:rPr>
               <a:t>B. 差別化メッセージ</a:t>
             </a:r>
-            <a:endParaRPr lang="en-US" sz="1250" dirty="0"/>
+            <a:endParaRPr lang="en-US" sz="1200" dirty="0"/>
           </a:p>
         </p:txBody>
       </p:sp>
@@ -3905,8 +4180,8 @@
         </p:nvSpPr>
         <p:spPr>
           <a:xfrm>
-            <a:off x="3410712" y="2194560"/>
-            <a:ext cx="2377440" cy="1097280"/>
+            <a:off x="3410712" y="2148840"/>
+            <a:ext cx="2377440" cy="1051560"/>
           </a:xfrm>
           <a:prstGeom prst="rect">
             <a:avLst/>
@@ -3922,7 +4197,7 @@
               <a:buNone/>
             </a:pPr>
             <a:r>
-              <a:rPr lang="en-US" sz="1100" b="1" dirty="0">
+              <a:rPr lang="en-US" sz="1200" b="1" dirty="0">
                 <a:solidFill>
                   <a:srgbClr val="0E7C86"/>
                 </a:solidFill>
@@ -3930,13 +4205,13 @@
                 <a:ea typeface="Yu Gothic UI" pitchFamily="34" charset="-122"/>
                 <a:cs typeface="Yu Gothic UI" pitchFamily="34" charset="-120"/>
               </a:rPr>
-              <a:t>✓ </a:t>
-            </a:r>
-            <a:pPr indent="0" marL="0">
-              <a:buNone/>
-            </a:pPr>
-            <a:r>
-              <a:rPr lang="en-US" sz="1100" dirty="0">
+              <a:t>✓  </a:t>
+            </a:r>
+            <a:pPr indent="0" marL="0">
+              <a:buNone/>
+            </a:pPr>
+            <a:r>
+              <a:rPr lang="en-US" sz="1050" dirty="0">
                 <a:solidFill>
                   <a:srgbClr val="1A1A1A"/>
                 </a:solidFill>
@@ -3946,7 +4221,7 @@
               </a:rPr>
               <a:t>同業他社ではなく「私だから選ぶ理由」が伝わる文言になっているか</a:t>
             </a:r>
-            <a:endParaRPr lang="en-US" sz="1100" dirty="0"/>
+            <a:endParaRPr lang="en-US" sz="1050" dirty="0"/>
           </a:p>
         </p:txBody>
       </p:sp>
@@ -3958,7 +4233,7 @@
         </p:nvSpPr>
         <p:spPr>
           <a:xfrm>
-            <a:off x="3410712" y="3383280"/>
+            <a:off x="3410712" y="3200400"/>
             <a:ext cx="2377440" cy="1188720"/>
           </a:xfrm>
           <a:prstGeom prst="rect">
@@ -3975,7 +4250,7 @@
               <a:buNone/>
             </a:pPr>
             <a:r>
-              <a:rPr lang="en-US" sz="1100" b="1" dirty="0">
+              <a:rPr lang="en-US" sz="1200" b="1" dirty="0">
                 <a:solidFill>
                   <a:srgbClr val="E8A33D"/>
                 </a:solidFill>
@@ -3983,13 +4258,13 @@
                 <a:ea typeface="Yu Gothic UI" pitchFamily="34" charset="-122"/>
                 <a:cs typeface="Yu Gothic UI" pitchFamily="34" charset="-120"/>
               </a:rPr>
-              <a:t>💡 </a:t>
-            </a:r>
-            <a:pPr indent="0" marL="0">
-              <a:buNone/>
-            </a:pPr>
-            <a:r>
-              <a:rPr lang="en-US" sz="1100" dirty="0">
+              <a:t>💡  </a:t>
+            </a:r>
+            <a:pPr indent="0" marL="0">
+              <a:buNone/>
+            </a:pPr>
+            <a:r>
+              <a:rPr lang="en-US" sz="1050" dirty="0">
                 <a:solidFill>
                   <a:srgbClr val="1A1A1A"/>
                 </a:solidFill>
@@ -3999,7 +4274,7 @@
               </a:rPr>
               <a:t>「3軸の3つ目=立ち位置」を AI に「キャッチコピーに反映して」と追加指示</a:t>
             </a:r>
-            <a:endParaRPr lang="en-US" sz="1100" dirty="0"/>
+            <a:endParaRPr lang="en-US" sz="1050" dirty="0"/>
           </a:p>
         </p:txBody>
       </p:sp>
@@ -4012,19 +4287,19 @@
         <p:spPr>
           <a:xfrm>
             <a:off x="6080760" y="1188720"/>
-            <a:ext cx="2651760" cy="3520440"/>
+            <a:ext cx="2651760" cy="3291840"/>
           </a:xfrm>
           <a:prstGeom prst="roundRect">
             <a:avLst>
-              <a:gd name="adj" fmla="val 2759"/>
+              <a:gd name="adj" fmla="val 3448"/>
             </a:avLst>
           </a:prstGeom>
           <a:solidFill>
             <a:srgbClr val="F4F6F9"/>
           </a:solidFill>
-          <a:ln w="6350">
+          <a:ln w="15240">
             <a:solidFill>
-              <a:srgbClr val="D7DCE3"/>
+              <a:srgbClr val="7C5F8A"/>
             </a:solidFill>
             <a:prstDash val="solid"/>
           </a:ln>
@@ -4039,13 +4314,13 @@
         <p:spPr>
           <a:xfrm>
             <a:off x="6080760" y="1188720"/>
-            <a:ext cx="2651760" cy="411480"/>
-          </a:xfrm>
-          <a:prstGeom prst="rect">
-            <a:avLst/>
-          </a:prstGeom>
-          <a:solidFill>
-            <a:srgbClr val="0E7C86"/>
+            <a:ext cx="2651760" cy="384048"/>
+          </a:xfrm>
+          <a:prstGeom prst="rect">
+            <a:avLst/>
+          </a:prstGeom>
+          <a:solidFill>
+            <a:srgbClr val="7C5F8A"/>
           </a:solidFill>
           <a:ln/>
         </p:spPr>
@@ -4058,8 +4333,8 @@
         </p:nvSpPr>
         <p:spPr>
           <a:xfrm>
-            <a:off x="6172200" y="1225296"/>
-            <a:ext cx="2468880" cy="329184"/>
+            <a:off x="6190488" y="1225296"/>
+            <a:ext cx="2432304" cy="310896"/>
           </a:xfrm>
           <a:prstGeom prst="rect">
             <a:avLst/>
@@ -4097,7 +4372,7 @@
         </p:nvSpPr>
         <p:spPr>
           <a:xfrm>
-            <a:off x="6245352" y="1691640"/>
+            <a:off x="6245352" y="1645920"/>
             <a:ext cx="2377440" cy="457200"/>
           </a:xfrm>
           <a:prstGeom prst="rect">
@@ -4114,7 +4389,7 @@
               <a:buNone/>
             </a:pPr>
             <a:r>
-              <a:rPr lang="en-US" sz="1250" b="1" dirty="0">
+              <a:rPr lang="en-US" sz="1200" b="1" dirty="0">
                 <a:solidFill>
                   <a:srgbClr val="1F3A5F"/>
                 </a:solidFill>
@@ -4124,7 +4399,7 @@
               </a:rPr>
               <a:t>C. CTA の心理ハードル</a:t>
             </a:r>
-            <a:endParaRPr lang="en-US" sz="1250" dirty="0"/>
+            <a:endParaRPr lang="en-US" sz="1200" dirty="0"/>
           </a:p>
         </p:txBody>
       </p:sp>
@@ -4136,8 +4411,8 @@
         </p:nvSpPr>
         <p:spPr>
           <a:xfrm>
-            <a:off x="6245352" y="2194560"/>
-            <a:ext cx="2377440" cy="1097280"/>
+            <a:off x="6245352" y="2148840"/>
+            <a:ext cx="2377440" cy="1051560"/>
           </a:xfrm>
           <a:prstGeom prst="rect">
             <a:avLst/>
@@ -4153,7 +4428,7 @@
               <a:buNone/>
             </a:pPr>
             <a:r>
-              <a:rPr lang="en-US" sz="1100" b="1" dirty="0">
+              <a:rPr lang="en-US" sz="1200" b="1" dirty="0">
                 <a:solidFill>
                   <a:srgbClr val="0E7C86"/>
                 </a:solidFill>
@@ -4161,13 +4436,13 @@
                 <a:ea typeface="Yu Gothic UI" pitchFamily="34" charset="-122"/>
                 <a:cs typeface="Yu Gothic UI" pitchFamily="34" charset="-120"/>
               </a:rPr>
-              <a:t>✓ </a:t>
-            </a:r>
-            <a:pPr indent="0" marL="0">
-              <a:buNone/>
-            </a:pPr>
-            <a:r>
-              <a:rPr lang="en-US" sz="1100" dirty="0">
+              <a:t>✓  </a:t>
+            </a:r>
+            <a:pPr indent="0" marL="0">
+              <a:buNone/>
+            </a:pPr>
+            <a:r>
+              <a:rPr lang="en-US" sz="1050" dirty="0">
                 <a:solidFill>
                   <a:srgbClr val="1A1A1A"/>
                 </a:solidFill>
@@ -4177,7 +4452,7 @@
               </a:rPr>
               <a:t>「公式LINE登録」が "次の一歩" に感じられる柔らかい文言か</a:t>
             </a:r>
-            <a:endParaRPr lang="en-US" sz="1100" dirty="0"/>
+            <a:endParaRPr lang="en-US" sz="1050" dirty="0"/>
           </a:p>
         </p:txBody>
       </p:sp>
@@ -4189,7 +4464,7 @@
         </p:nvSpPr>
         <p:spPr>
           <a:xfrm>
-            <a:off x="6245352" y="3383280"/>
+            <a:off x="6245352" y="3200400"/>
             <a:ext cx="2377440" cy="1188720"/>
           </a:xfrm>
           <a:prstGeom prst="rect">
@@ -4206,7 +4481,7 @@
               <a:buNone/>
             </a:pPr>
             <a:r>
-              <a:rPr lang="en-US" sz="1100" b="1" dirty="0">
+              <a:rPr lang="en-US" sz="1200" b="1" dirty="0">
                 <a:solidFill>
                   <a:srgbClr val="E8A33D"/>
                 </a:solidFill>
@@ -4214,13 +4489,13 @@
                 <a:ea typeface="Yu Gothic UI" pitchFamily="34" charset="-122"/>
                 <a:cs typeface="Yu Gothic UI" pitchFamily="34" charset="-120"/>
               </a:rPr>
-              <a:t>💡 </a:t>
-            </a:r>
-            <a:pPr indent="0" marL="0">
-              <a:buNone/>
-            </a:pPr>
-            <a:r>
-              <a:rPr lang="en-US" sz="1100" dirty="0">
+              <a:t>💡  </a:t>
+            </a:r>
+            <a:pPr indent="0" marL="0">
+              <a:buNone/>
+            </a:pPr>
+            <a:r>
+              <a:rPr lang="en-US" sz="1050" dirty="0">
                 <a:solidFill>
                   <a:srgbClr val="1A1A1A"/>
                 </a:solidFill>
@@ -4230,7 +4505,7 @@
               </a:rPr>
               <a:t>「無料相談」「資料請求」より「LINEで気軽に質問」など心理ハードルを下げる</a:t>
             </a:r>
-            <a:endParaRPr lang="en-US" sz="1100" dirty="0"/>
+            <a:endParaRPr lang="en-US" sz="1050" dirty="0"/>
           </a:p>
         </p:txBody>
       </p:sp>
@@ -4939,7 +5214,7 @@
                 <a:ea typeface="Yu Gothic UI" pitchFamily="34" charset="-122"/>
                 <a:cs typeface="Yu Gothic UI" pitchFamily="34" charset="-120"/>
               </a:rPr>
-              <a:t>プロンプトをさらにブラッシュアップ</a:t>
+              <a:t>プロンプトをさらにブラッシュアップ — 3観点でセルフチェック</a:t>
             </a:r>
             <a:endParaRPr lang="en-US" sz="1300" dirty="0"/>
           </a:p>
@@ -4954,19 +5229,19 @@
         <p:spPr>
           <a:xfrm>
             <a:off x="411480" y="1188720"/>
-            <a:ext cx="2651760" cy="3520440"/>
+            <a:ext cx="2651760" cy="3291840"/>
           </a:xfrm>
           <a:prstGeom prst="roundRect">
             <a:avLst>
-              <a:gd name="adj" fmla="val 2759"/>
+              <a:gd name="adj" fmla="val 3448"/>
             </a:avLst>
           </a:prstGeom>
           <a:solidFill>
             <a:srgbClr val="F4F6F9"/>
           </a:solidFill>
-          <a:ln w="6350">
+          <a:ln w="15240">
             <a:solidFill>
-              <a:srgbClr val="D7DCE3"/>
+              <a:srgbClr val="0E7C86"/>
             </a:solidFill>
             <a:prstDash val="solid"/>
           </a:ln>
@@ -4981,7 +5256,7 @@
         <p:spPr>
           <a:xfrm>
             <a:off x="411480" y="1188720"/>
-            <a:ext cx="2651760" cy="411480"/>
+            <a:ext cx="2651760" cy="384048"/>
           </a:xfrm>
           <a:prstGeom prst="rect">
             <a:avLst/>
@@ -5000,8 +5275,8 @@
         </p:nvSpPr>
         <p:spPr>
           <a:xfrm>
-            <a:off x="502920" y="1225296"/>
-            <a:ext cx="2468880" cy="329184"/>
+            <a:off x="521208" y="1225296"/>
+            <a:ext cx="2432304" cy="310896"/>
           </a:xfrm>
           <a:prstGeom prst="rect">
             <a:avLst/>
@@ -5039,7 +5314,7 @@
         </p:nvSpPr>
         <p:spPr>
           <a:xfrm>
-            <a:off x="576072" y="1691640"/>
+            <a:off x="576072" y="1645920"/>
             <a:ext cx="2377440" cy="457200"/>
           </a:xfrm>
           <a:prstGeom prst="rect">
@@ -5056,7 +5331,7 @@
               <a:buNone/>
             </a:pPr>
             <a:r>
-              <a:rPr lang="en-US" sz="1250" b="1" dirty="0">
+              <a:rPr lang="en-US" sz="1200" b="1" dirty="0">
                 <a:solidFill>
                   <a:srgbClr val="1F3A5F"/>
                 </a:solidFill>
@@ -5066,7 +5341,7 @@
               </a:rPr>
               <a:t>A. 段階の解像度</a:t>
             </a:r>
-            <a:endParaRPr lang="en-US" sz="1250" dirty="0"/>
+            <a:endParaRPr lang="en-US" sz="1200" dirty="0"/>
           </a:p>
         </p:txBody>
       </p:sp>
@@ -5078,8 +5353,8 @@
         </p:nvSpPr>
         <p:spPr>
           <a:xfrm>
-            <a:off x="576072" y="2194560"/>
-            <a:ext cx="2377440" cy="1097280"/>
+            <a:off x="576072" y="2148840"/>
+            <a:ext cx="2377440" cy="1051560"/>
           </a:xfrm>
           <a:prstGeom prst="rect">
             <a:avLst/>
@@ -5095,7 +5370,7 @@
               <a:buNone/>
             </a:pPr>
             <a:r>
-              <a:rPr lang="en-US" sz="1100" b="1" dirty="0">
+              <a:rPr lang="en-US" sz="1200" b="1" dirty="0">
                 <a:solidFill>
                   <a:srgbClr val="0E7C86"/>
                 </a:solidFill>
@@ -5103,13 +5378,13 @@
                 <a:ea typeface="Yu Gothic UI" pitchFamily="34" charset="-122"/>
                 <a:cs typeface="Yu Gothic UI" pitchFamily="34" charset="-120"/>
               </a:rPr>
-              <a:t>✓ </a:t>
-            </a:r>
-            <a:pPr indent="0" marL="0">
-              <a:buNone/>
-            </a:pPr>
-            <a:r>
-              <a:rPr lang="en-US" sz="1100" dirty="0">
+              <a:t>✓  </a:t>
+            </a:r>
+            <a:pPr indent="0" marL="0">
+              <a:buNone/>
+            </a:pPr>
+            <a:r>
+              <a:rPr lang="en-US" sz="1050" dirty="0">
                 <a:solidFill>
                   <a:srgbClr val="1A1A1A"/>
                 </a:solidFill>
@@ -5119,7 +5394,7 @@
               </a:rPr>
               <a:t>注目→興味→欲求→記憶→行動 の5段階で「何が違うか」が言えるか</a:t>
             </a:r>
-            <a:endParaRPr lang="en-US" sz="1100" dirty="0"/>
+            <a:endParaRPr lang="en-US" sz="1050" dirty="0"/>
           </a:p>
         </p:txBody>
       </p:sp>
@@ -5131,7 +5406,7 @@
         </p:nvSpPr>
         <p:spPr>
           <a:xfrm>
-            <a:off x="576072" y="3383280"/>
+            <a:off x="576072" y="3200400"/>
             <a:ext cx="2377440" cy="1188720"/>
           </a:xfrm>
           <a:prstGeom prst="rect">
@@ -5148,7 +5423,7 @@
               <a:buNone/>
             </a:pPr>
             <a:r>
-              <a:rPr lang="en-US" sz="1100" b="1" dirty="0">
+              <a:rPr lang="en-US" sz="1200" b="1" dirty="0">
                 <a:solidFill>
                   <a:srgbClr val="E8A33D"/>
                 </a:solidFill>
@@ -5156,13 +5431,13 @@
                 <a:ea typeface="Yu Gothic UI" pitchFamily="34" charset="-122"/>
                 <a:cs typeface="Yu Gothic UI" pitchFamily="34" charset="-120"/>
               </a:rPr>
-              <a:t>💡 </a:t>
-            </a:r>
-            <a:pPr indent="0" marL="0">
-              <a:buNone/>
-            </a:pPr>
-            <a:r>
-              <a:rPr lang="en-US" sz="1100" dirty="0">
+              <a:t>💡  </a:t>
+            </a:r>
+            <a:pPr indent="0" marL="0">
+              <a:buNone/>
+            </a:pPr>
+            <a:r>
+              <a:rPr lang="en-US" sz="1050" dirty="0">
                 <a:solidFill>
                   <a:srgbClr val="1A1A1A"/>
                 </a:solidFill>
@@ -5172,7 +5447,7 @@
               </a:rPr>
               <a:t>「興味=知りたい / 欲求=自分ごと / 行動=予約する」と言葉で区別させる</a:t>
             </a:r>
-            <a:endParaRPr lang="en-US" sz="1100" dirty="0"/>
+            <a:endParaRPr lang="en-US" sz="1050" dirty="0"/>
           </a:p>
         </p:txBody>
       </p:sp>
@@ -5185,19 +5460,19 @@
         <p:spPr>
           <a:xfrm>
             <a:off x="3246120" y="1188720"/>
-            <a:ext cx="2651760" cy="3520440"/>
+            <a:ext cx="2651760" cy="3291840"/>
           </a:xfrm>
           <a:prstGeom prst="roundRect">
             <a:avLst>
-              <a:gd name="adj" fmla="val 2759"/>
+              <a:gd name="adj" fmla="val 3448"/>
             </a:avLst>
           </a:prstGeom>
           <a:solidFill>
             <a:srgbClr val="F4F6F9"/>
           </a:solidFill>
-          <a:ln w="6350">
+          <a:ln w="15240">
             <a:solidFill>
-              <a:srgbClr val="D7DCE3"/>
+              <a:srgbClr val="E8A33D"/>
             </a:solidFill>
             <a:prstDash val="solid"/>
           </a:ln>
@@ -5212,13 +5487,13 @@
         <p:spPr>
           <a:xfrm>
             <a:off x="3246120" y="1188720"/>
-            <a:ext cx="2651760" cy="411480"/>
-          </a:xfrm>
-          <a:prstGeom prst="rect">
-            <a:avLst/>
-          </a:prstGeom>
-          <a:solidFill>
-            <a:srgbClr val="0E7C86"/>
+            <a:ext cx="2651760" cy="384048"/>
+          </a:xfrm>
+          <a:prstGeom prst="rect">
+            <a:avLst/>
+          </a:prstGeom>
+          <a:solidFill>
+            <a:srgbClr val="E8A33D"/>
           </a:solidFill>
           <a:ln/>
         </p:spPr>
@@ -5231,8 +5506,8 @@
         </p:nvSpPr>
         <p:spPr>
           <a:xfrm>
-            <a:off x="3337560" y="1225296"/>
-            <a:ext cx="2468880" cy="329184"/>
+            <a:off x="3355848" y="1225296"/>
+            <a:ext cx="2432304" cy="310896"/>
           </a:xfrm>
           <a:prstGeom prst="rect">
             <a:avLst/>
@@ -5270,7 +5545,7 @@
         </p:nvSpPr>
         <p:spPr>
           <a:xfrm>
-            <a:off x="3410712" y="1691640"/>
+            <a:off x="3410712" y="1645920"/>
             <a:ext cx="2377440" cy="457200"/>
           </a:xfrm>
           <a:prstGeom prst="rect">
@@ -5287,7 +5562,7 @@
               <a:buNone/>
             </a:pPr>
             <a:r>
-              <a:rPr lang="en-US" sz="1250" b="1" dirty="0">
+              <a:rPr lang="en-US" sz="1200" b="1" dirty="0">
                 <a:solidFill>
                   <a:srgbClr val="1F3A5F"/>
                 </a:solidFill>
@@ -5297,7 +5572,7 @@
               </a:rPr>
               <a:t>B. 離脱対策</a:t>
             </a:r>
-            <a:endParaRPr lang="en-US" sz="1250" dirty="0"/>
+            <a:endParaRPr lang="en-US" sz="1200" dirty="0"/>
           </a:p>
         </p:txBody>
       </p:sp>
@@ -5309,8 +5584,8 @@
         </p:nvSpPr>
         <p:spPr>
           <a:xfrm>
-            <a:off x="3410712" y="2194560"/>
-            <a:ext cx="2377440" cy="1097280"/>
+            <a:off x="3410712" y="2148840"/>
+            <a:ext cx="2377440" cy="1051560"/>
           </a:xfrm>
           <a:prstGeom prst="rect">
             <a:avLst/>
@@ -5326,7 +5601,7 @@
               <a:buNone/>
             </a:pPr>
             <a:r>
-              <a:rPr lang="en-US" sz="1100" b="1" dirty="0">
+              <a:rPr lang="en-US" sz="1200" b="1" dirty="0">
                 <a:solidFill>
                   <a:srgbClr val="0E7C86"/>
                 </a:solidFill>
@@ -5334,13 +5609,13 @@
                 <a:ea typeface="Yu Gothic UI" pitchFamily="34" charset="-122"/>
                 <a:cs typeface="Yu Gothic UI" pitchFamily="34" charset="-120"/>
               </a:rPr>
-              <a:t>✓ </a:t>
-            </a:r>
-            <a:pPr indent="0" marL="0">
-              <a:buNone/>
-            </a:pPr>
-            <a:r>
-              <a:rPr lang="en-US" sz="1100" dirty="0">
+              <a:t>✓  </a:t>
+            </a:r>
+            <a:pPr indent="0" marL="0">
+              <a:buNone/>
+            </a:pPr>
+            <a:r>
+              <a:rPr lang="en-US" sz="1050" dirty="0">
                 <a:solidFill>
                   <a:srgbClr val="1A1A1A"/>
                 </a:solidFill>
@@ -5350,7 +5625,7 @@
               </a:rPr>
               <a:t>各段階で「離脱しそうな人」へのフォロー文が用意できているか</a:t>
             </a:r>
-            <a:endParaRPr lang="en-US" sz="1100" dirty="0"/>
+            <a:endParaRPr lang="en-US" sz="1050" dirty="0"/>
           </a:p>
         </p:txBody>
       </p:sp>
@@ -5362,7 +5637,7 @@
         </p:nvSpPr>
         <p:spPr>
           <a:xfrm>
-            <a:off x="3410712" y="3383280"/>
+            <a:off x="3410712" y="3200400"/>
             <a:ext cx="2377440" cy="1188720"/>
           </a:xfrm>
           <a:prstGeom prst="rect">
@@ -5379,7 +5654,7 @@
               <a:buNone/>
             </a:pPr>
             <a:r>
-              <a:rPr lang="en-US" sz="1100" b="1" dirty="0">
+              <a:rPr lang="en-US" sz="1200" b="1" dirty="0">
                 <a:solidFill>
                   <a:srgbClr val="E8A33D"/>
                 </a:solidFill>
@@ -5387,13 +5662,13 @@
                 <a:ea typeface="Yu Gothic UI" pitchFamily="34" charset="-122"/>
                 <a:cs typeface="Yu Gothic UI" pitchFamily="34" charset="-120"/>
               </a:rPr>
-              <a:t>💡 </a:t>
-            </a:r>
-            <a:pPr indent="0" marL="0">
-              <a:buNone/>
-            </a:pPr>
-            <a:r>
-              <a:rPr lang="en-US" sz="1100" dirty="0">
+              <a:t>💡  </a:t>
+            </a:r>
+            <a:pPr indent="0" marL="0">
+              <a:buNone/>
+            </a:pPr>
+            <a:r>
+              <a:rPr lang="en-US" sz="1050" dirty="0">
                 <a:solidFill>
                   <a:srgbClr val="1A1A1A"/>
                 </a:solidFill>
@@ -5403,7 +5678,7 @@
               </a:rPr>
               <a:t>「迷っている方へ」「もし不安があれば」などの分岐メッセージを AI に出させる</a:t>
             </a:r>
-            <a:endParaRPr lang="en-US" sz="1100" dirty="0"/>
+            <a:endParaRPr lang="en-US" sz="1050" dirty="0"/>
           </a:p>
         </p:txBody>
       </p:sp>
@@ -5416,19 +5691,19 @@
         <p:spPr>
           <a:xfrm>
             <a:off x="6080760" y="1188720"/>
-            <a:ext cx="2651760" cy="3520440"/>
+            <a:ext cx="2651760" cy="3291840"/>
           </a:xfrm>
           <a:prstGeom prst="roundRect">
             <a:avLst>
-              <a:gd name="adj" fmla="val 2759"/>
+              <a:gd name="adj" fmla="val 3448"/>
             </a:avLst>
           </a:prstGeom>
           <a:solidFill>
             <a:srgbClr val="F4F6F9"/>
           </a:solidFill>
-          <a:ln w="6350">
+          <a:ln w="15240">
             <a:solidFill>
-              <a:srgbClr val="D7DCE3"/>
+              <a:srgbClr val="7C5F8A"/>
             </a:solidFill>
             <a:prstDash val="solid"/>
           </a:ln>
@@ -5443,13 +5718,13 @@
         <p:spPr>
           <a:xfrm>
             <a:off x="6080760" y="1188720"/>
-            <a:ext cx="2651760" cy="411480"/>
-          </a:xfrm>
-          <a:prstGeom prst="rect">
-            <a:avLst/>
-          </a:prstGeom>
-          <a:solidFill>
-            <a:srgbClr val="0E7C86"/>
+            <a:ext cx="2651760" cy="384048"/>
+          </a:xfrm>
+          <a:prstGeom prst="rect">
+            <a:avLst/>
+          </a:prstGeom>
+          <a:solidFill>
+            <a:srgbClr val="7C5F8A"/>
           </a:solidFill>
           <a:ln/>
         </p:spPr>
@@ -5462,8 +5737,8 @@
         </p:nvSpPr>
         <p:spPr>
           <a:xfrm>
-            <a:off x="6172200" y="1225296"/>
-            <a:ext cx="2468880" cy="329184"/>
+            <a:off x="6190488" y="1225296"/>
+            <a:ext cx="2432304" cy="310896"/>
           </a:xfrm>
           <a:prstGeom prst="rect">
             <a:avLst/>
@@ -5501,7 +5776,7 @@
         </p:nvSpPr>
         <p:spPr>
           <a:xfrm>
-            <a:off x="6245352" y="1691640"/>
+            <a:off x="6245352" y="1645920"/>
             <a:ext cx="2377440" cy="457200"/>
           </a:xfrm>
           <a:prstGeom prst="rect">
@@ -5518,7 +5793,7 @@
               <a:buNone/>
             </a:pPr>
             <a:r>
-              <a:rPr lang="en-US" sz="1250" b="1" dirty="0">
+              <a:rPr lang="en-US" sz="1200" b="1" dirty="0">
                 <a:solidFill>
                   <a:srgbClr val="1F3A5F"/>
                 </a:solidFill>
@@ -5528,7 +5803,7 @@
               </a:rPr>
               <a:t>C. 行動への橋渡し</a:t>
             </a:r>
-            <a:endParaRPr lang="en-US" sz="1250" dirty="0"/>
+            <a:endParaRPr lang="en-US" sz="1200" dirty="0"/>
           </a:p>
         </p:txBody>
       </p:sp>
@@ -5540,8 +5815,8 @@
         </p:nvSpPr>
         <p:spPr>
           <a:xfrm>
-            <a:off x="6245352" y="2194560"/>
-            <a:ext cx="2377440" cy="1097280"/>
+            <a:off x="6245352" y="2148840"/>
+            <a:ext cx="2377440" cy="1051560"/>
           </a:xfrm>
           <a:prstGeom prst="rect">
             <a:avLst/>
@@ -5557,7 +5832,7 @@
               <a:buNone/>
             </a:pPr>
             <a:r>
-              <a:rPr lang="en-US" sz="1100" b="1" dirty="0">
+              <a:rPr lang="en-US" sz="1200" b="1" dirty="0">
                 <a:solidFill>
                   <a:srgbClr val="0E7C86"/>
                 </a:solidFill>
@@ -5565,13 +5840,13 @@
                 <a:ea typeface="Yu Gothic UI" pitchFamily="34" charset="-122"/>
                 <a:cs typeface="Yu Gothic UI" pitchFamily="34" charset="-120"/>
               </a:rPr>
-              <a:t>✓ </a:t>
-            </a:r>
-            <a:pPr indent="0" marL="0">
-              <a:buNone/>
-            </a:pPr>
-            <a:r>
-              <a:rPr lang="en-US" sz="1100" dirty="0">
+              <a:t>✓  </a:t>
+            </a:r>
+            <a:pPr indent="0" marL="0">
+              <a:buNone/>
+            </a:pPr>
+            <a:r>
+              <a:rPr lang="en-US" sz="1050" dirty="0">
                 <a:solidFill>
                   <a:srgbClr val="1A1A1A"/>
                 </a:solidFill>
@@ -5581,7 +5856,7 @@
               </a:rPr>
               <a:t>最後の「行動」段階で、面談予約ページへの導線がはっきりしているか</a:t>
             </a:r>
-            <a:endParaRPr lang="en-US" sz="1100" dirty="0"/>
+            <a:endParaRPr lang="en-US" sz="1050" dirty="0"/>
           </a:p>
         </p:txBody>
       </p:sp>
@@ -5593,7 +5868,7 @@
         </p:nvSpPr>
         <p:spPr>
           <a:xfrm>
-            <a:off x="6245352" y="3383280"/>
+            <a:off x="6245352" y="3200400"/>
             <a:ext cx="2377440" cy="1188720"/>
           </a:xfrm>
           <a:prstGeom prst="rect">
@@ -5610,7 +5885,7 @@
               <a:buNone/>
             </a:pPr>
             <a:r>
-              <a:rPr lang="en-US" sz="1100" b="1" dirty="0">
+              <a:rPr lang="en-US" sz="1200" b="1" dirty="0">
                 <a:solidFill>
                   <a:srgbClr val="E8A33D"/>
                 </a:solidFill>
@@ -5618,13 +5893,13 @@
                 <a:ea typeface="Yu Gothic UI" pitchFamily="34" charset="-122"/>
                 <a:cs typeface="Yu Gothic UI" pitchFamily="34" charset="-120"/>
               </a:rPr>
-              <a:t>💡 </a:t>
-            </a:r>
-            <a:pPr indent="0" marL="0">
-              <a:buNone/>
-            </a:pPr>
-            <a:r>
-              <a:rPr lang="en-US" sz="1100" dirty="0">
+              <a:t>💡  </a:t>
+            </a:r>
+            <a:pPr indent="0" marL="0">
+              <a:buNone/>
+            </a:pPr>
+            <a:r>
+              <a:rPr lang="en-US" sz="1050" dirty="0">
                 <a:solidFill>
                   <a:srgbClr val="1A1A1A"/>
                 </a:solidFill>
@@ -5634,7 +5909,7 @@
               </a:rPr>
               <a:t>予約URL を本文に直接埋め、リッチメニューにも同じ予約ボタンを置く</a:t>
             </a:r>
-            <a:endParaRPr lang="en-US" sz="1100" dirty="0"/>
+            <a:endParaRPr lang="en-US" sz="1050" dirty="0"/>
           </a:p>
         </p:txBody>
       </p:sp>

</xml_diff>